<commit_message>
feat: add grounded answers and native tool calling
Co-authored-by: Copilot <223556219+Copilot@users.noreply.github.com>
</commit_message>
<xml_diff>
--- a/presentation/agentic-customer-support.pptx
+++ b/presentation/agentic-customer-support.pptx
@@ -3643,7 +3643,7 @@
               </a:defRPr>
             </a:pPr>
             <a:r>
-              <a:t>Next: compliant tool-calling/ReAct path and grounded product answer generation</a:t>
+              <a:t>Separate live Groq product-answer and native-tool smoke checks passed</a:t>
             </a:r>
           </a:p>
           <a:p>
@@ -3659,7 +3659,7 @@
               </a:defRPr>
             </a:pPr>
             <a:r>
-              <a:t>Then: live interruption follow-up validation and acoustic latency measurement</a:t>
+              <a:t>Next: speech follow-up and acoustic latency measurement</a:t>
             </a:r>
           </a:p>
         </p:txBody>
@@ -4247,7 +4247,7 @@
                 </a:solidFill>
                 <a:latin typeface="Aptos"/>
               </a:rPr>
-              <a:t>Grounding and implementation gaps</a:t>
+              <a:t>Grounded answers and tool-calling choice</a:t>
             </a:r>
           </a:p>
         </p:txBody>
@@ -4318,7 +4318,7 @@
               </a:defRPr>
             </a:pPr>
             <a:r>
-              <a:t>Product handler retrieves passages but does not yet generate a grounded answer</a:t>
+              <a:t>Product answers cite retrieved chunks; only cited facts reach the output claim guard</a:t>
             </a:r>
           </a:p>
           <a:p>
@@ -4334,7 +4334,7 @@
               </a:defRPr>
             </a:pPr>
             <a:r>
-              <a:t>Tool dispatch is deterministic; native function calling/ReAct is not implemented</a:t>
+              <a:t>Native Groq calls select one allow-listed tool; local code validates arguments and ownership</a:t>
             </a:r>
           </a:p>
         </p:txBody>
@@ -4511,7 +4511,7 @@
               </a:defRPr>
             </a:pPr>
             <a:r>
-              <a:t>Keyless regression suite: 62 passed; 2 dependency deprecation warnings</a:t>
+              <a:t>Keyless suite: 81 passed, 2 live checks skipped; 2 dependency warnings</a:t>
             </a:r>
           </a:p>
           <a:p>

</xml_diff>

<commit_message>
feat: finalize voice evidence and submission package
</commit_message>
<xml_diff>
--- a/presentation/agentic-customer-support.pptx
+++ b/presentation/agentic-customer-support.pptx
@@ -3244,7 +3244,7 @@
               </a:defRPr>
             </a:pPr>
             <a:r>
-              <a:t>Status: Step 8 live follow-up acceptance remains incomplete</a:t>
+              <a:t>Status: recorded-audio follow-ups pass; live latency remains high</a:t>
             </a:r>
           </a:p>
         </p:txBody>
@@ -3659,7 +3659,7 @@
               </a:defRPr>
             </a:pPr>
             <a:r>
-              <a:t>Next: speech follow-up and acoustic latency measurement</a:t>
+              <a:t>Next: reduce voice latency, measure acoustic output, practice unaided</a:t>
             </a:r>
           </a:p>
         </p:txBody>
@@ -4511,7 +4511,7 @@
               </a:defRPr>
             </a:pPr>
             <a:r>
-              <a:t>Keyless suite: 81 passed, 2 live checks skipped; 2 dependency warnings</a:t>
+              <a:t>Keyless suite: 89 passed, 2 live checks skipped; 2 dependency warnings</a:t>
             </a:r>
           </a:p>
           <a:p>
@@ -4977,7 +4977,7 @@
               </a:defRPr>
             </a:pPr>
             <a:r>
-              <a:t>Wrong-order speech interrupted; live input safety failed closed</a:t>
+              <a:t>Normal order, return eligibility, and wrong-order follow-ups completed safely</a:t>
             </a:r>
           </a:p>
           <a:p>
@@ -4993,7 +4993,7 @@
               </a:defRPr>
             </a:pPr>
             <a:r>
-              <a:t>Adversarial speech interrupted; live classifier failed closed; no refund promised</a:t>
+              <a:t>Adversarial follow-up escalated; no refund promise or stale response</a:t>
             </a:r>
           </a:p>
           <a:p>
@@ -5186,7 +5186,7 @@
               </a:defRPr>
             </a:pPr>
             <a:r>
-              <a:t>Wrong-order: 3665.86 ms to application playback start</a:t>
+              <a:t>Successful speech follow-ups: 19,293.912-20,168.889 ms to app playback start</a:t>
             </a:r>
           </a:p>
           <a:p>
@@ -5202,7 +5202,7 @@
               </a:defRPr>
             </a:pPr>
             <a:r>
-              <a:t>Adversarial: 5672.024 ms; injected failure handoff: 2585.583 ms</a:t>
+              <a:t>Injected failure handoff: 15,886.752 ms; cancellation call: 105-128 ms</a:t>
             </a:r>
           </a:p>
           <a:p>
@@ -5218,7 +5218,7 @@
               </a:defRPr>
             </a:pPr>
             <a:r>
-              <a:t>Timestamps are real; endpoint is application playback handoff</a:t>
+              <a:t>App playback-start latency is not first-acoustic-sample latency</a:t>
             </a:r>
           </a:p>
           <a:p>
@@ -5234,7 +5234,7 @@
               </a:defRPr>
             </a:pPr>
             <a:r>
-              <a:t>No acoustic loopback or first-physical-sample measurement</a:t>
+              <a:t>All voice latency observations exceed proposed &lt;3 second target</a:t>
             </a:r>
           </a:p>
         </p:txBody>

</xml_diff>

<commit_message>
docs: red-team round 2, recall-oriented retrieval gate, final results
A live red-team run (scripts/run_red_team.py, 11 probes) confirmed six
defenses and reproduced four open weaknesses, documented with reasons they
were not fixed: a "my refund" policy question routed to the order tool, an
explicit human request naming an order answered without a handoff, the output
guard blocking a negated "refund is approved" sentence (pinned by a strict
xfail test), and a romanized Hindi question answered in Devanagari.

Two answerable probes were rejected by the retrieval gate. Because e5 top
scores for answerable and unanswerable questions overlap and the answerer
declined every near-miss, the gate is now tuned for recall (0.8106): live
answerable answered 0.906 -> 0.938, near-misses still declined 13/13.

README, design notes, evaluation, retrieval design, Part C answers, runbook,
and the presentation now reflect the measured final state.

Co-Authored-By: Claude Opus 5.5 <noreply@anthropic.com>
</commit_message>
<xml_diff>
--- a/presentation/agentic-customer-support.pptx
+++ b/presentation/agentic-customer-support.pptx
@@ -3611,7 +3611,7 @@
               </a:defRPr>
             </a:pPr>
             <a:r>
-              <a:t>Voice-to-text/human shared-state transfer is designed, not implemented</a:t>
+              <a:t>Voice and text share session memory; handoffs carry a turn summary (process-local)</a:t>
             </a:r>
           </a:p>
           <a:p>
@@ -3836,7 +3836,7 @@
               </a:defRPr>
             </a:pPr>
             <a:r>
-              <a:t>Input shape checks -&gt; InputGuard -&gt; structured intent router</a:t>
+              <a:t>Input shape checks -&gt; InputGuard -&gt; hybrid router (rules, examples, LLM)</a:t>
             </a:r>
           </a:p>
           <a:p>
@@ -3852,7 +3852,7 @@
               </a:defRPr>
             </a:pPr>
             <a:r>
-              <a:t>Registered handler -&gt; read-only tools or semantic retrieval</a:t>
+              <a:t>Handler: read-only tools, hybrid retrieval, human handoff, or conversation agent</a:t>
             </a:r>
           </a:p>
           <a:p>
@@ -4286,7 +4286,7 @@
               </a:defRPr>
             </a:pPr>
             <a:r>
-              <a:t>12 original KB documents; local MiniLM embeddings and exact cosine scan</a:t>
+              <a:t>12 original KB documents; multilingual-e5-small + BM25 fusion, top-candidate gate</a:t>
             </a:r>
           </a:p>
           <a:p>
@@ -4302,7 +4302,7 @@
               </a:defRPr>
             </a:pPr>
             <a:r>
-              <a:t>Retrieval keeps source and chunk provenance; insufficient evidence is explicit</a:t>
+              <a:t>Retrieval gate tuned for recall; the answerer declines when evidence is insufficient</a:t>
             </a:r>
           </a:p>
           <a:p>
@@ -4472,7 +4472,7 @@
                 </a:solidFill>
                 <a:latin typeface="Aptos"/>
               </a:rPr>
-              <a:t>Measured offline baseline</a:t>
+              <a:t>Measured improvement on held-out sets</a:t>
             </a:r>
           </a:p>
         </p:txBody>
@@ -4511,7 +4511,7 @@
               </a:defRPr>
             </a:pPr>
             <a:r>
-              <a:t>Keyless suite: 89 passed, 2 live checks skipped; 2 dependency warnings</a:t>
+              <a:t>Live routing (110 cases): strict accuracy 0.509 -&gt; 0.955; dead ends 0.355 -&gt; 0.009</a:t>
             </a:r>
           </a:p>
           <a:p>
@@ -4527,7 +4527,7 @@
               </a:defRPr>
             </a:pPr>
             <a:r>
-              <a:t>Routing accuracy 0.8333; retrieval recall@5 0.7273</a:t>
+              <a:t>False escalations 0.117 -&gt; 0; LLM calls per message 1.28 -&gt; 0.245; p95 16.4 s -&gt; 0.70 s</a:t>
             </a:r>
           </a:p>
           <a:p>
@@ -4543,7 +4543,7 @@
               </a:defRPr>
             </a:pPr>
             <a:r>
-              <a:t>Input guardrail recall 0.6667; output guardrail recall 1.0</a:t>
+              <a:t>Retrieval (45 cases): evidence recall 0.516 -&gt; 0.922; live: 0.938 answered, 13/13 near-misses declined</a:t>
             </a:r>
           </a:p>
           <a:p>
@@ -4559,7 +4559,7 @@
               </a:defRPr>
             </a:pPr>
             <a:r>
-              <a:t>Classifier cache hit rate 0.5 on the measured workload</a:t>
+              <a:t>Keyless suite: 214 passed, 2 live skipped, 1 known-limitation xfail</a:t>
             </a:r>
           </a:p>
         </p:txBody>
@@ -5372,7 +5372,7 @@
                 </a:solidFill>
                 <a:latin typeface="Aptos"/>
               </a:rPr>
-              <a:t>Red-team: two reproduced gaps</a:t>
+              <a:t>Red-team: reproduced gaps (two rounds)</a:t>
             </a:r>
           </a:p>
         </p:txBody>
@@ -5411,7 +5411,7 @@
               </a:defRPr>
             </a:pPr>
             <a:r>
-              <a:t>safe=true with confidence 0.0 allowed an injection before the fix</a:t>
+              <a:t>Round 1 (fixed): low-confidence safe=true and unverified natural-language dates</a:t>
             </a:r>
           </a:p>
           <a:p>
@@ -5427,7 +5427,7 @@
               </a:defRPr>
             </a:pPr>
             <a:r>
-              <a:t>Natural-language unverified delivery date passed output validation before the fix</a:t>
+              <a:t>Round 2 (fixed): greeting dead ends, off-topic escalations, comparison crash</a:t>
             </a:r>
           </a:p>
           <a:p>
@@ -5443,7 +5443,7 @@
               </a:defRPr>
             </a:pPr>
             <a:r>
-              <a:t>Both fixes have service-boundary regression tests</a:t>
+              <a:t>Round 2 (open): 'my refund' policy question -&gt; order tool; human + order ID -&gt; no handoff</a:t>
             </a:r>
           </a:p>
           <a:p>
@@ -5459,7 +5459,7 @@
               </a:defRPr>
             </a:pPr>
             <a:r>
-              <a:t>Residual risks: semantic classifier errors and heuristic coverage</a:t>
+              <a:t>Round 2 (open): guard blocks negated 'refund is approved'; Hinglish answered in Devanagari</a:t>
             </a:r>
           </a:p>
         </p:txBody>

</xml_diff>